<commit_message>
Modified progess meeting presentation
</commit_message>
<xml_diff>
--- a/Presentations/Progess Meetings/2026-09-10.pptx
+++ b/Presentations/Progess Meetings/2026-09-10.pptx
@@ -508,7 +508,7 @@
           <a:p>
             <a:fld id="{A1362C08-F31F-417E-9DA2-FB0A727E2763}" type="datetimeFigureOut">
               <a:rPr lang="en-US" smtClean="0"/>
-              <a:t>9/10/2026</a:t>
+              <a:t>9/11/2026</a:t>
             </a:fld>
             <a:endParaRPr lang="en-US"/>
           </a:p>
@@ -685,7 +685,7 @@
           <a:p>
             <a:fld id="{3B58027B-B5CA-43FE-83BF-6327550A03F7}" type="datetimeFigureOut">
               <a:rPr lang="en-US" smtClean="0"/>
-              <a:t>9/10/2026</a:t>
+              <a:t>9/11/2026</a:t>
             </a:fld>
             <a:endParaRPr lang="en-US"/>
           </a:p>
@@ -950,6 +950,90 @@
     </a:lvl9pPr>
   </p:notesStyle>
 </p:notesMaster>
+</file>
+
+<file path=ppt/notesSlides/notesSlide1.xml><?xml version="1.0" encoding="utf-8"?>
+<p:notes xmlns:a="http://schemas.openxmlformats.org/drawingml/2006/main" xmlns:r="http://schemas.openxmlformats.org/officeDocument/2006/relationships" xmlns:p="http://schemas.openxmlformats.org/presentationml/2006/main">
+  <p:cSld>
+    <p:spTree>
+      <p:nvGrpSpPr>
+        <p:cNvPr id="1" name=""/>
+        <p:cNvGrpSpPr/>
+        <p:nvPr/>
+      </p:nvGrpSpPr>
+      <p:grpSpPr>
+        <a:xfrm>
+          <a:off x="0" y="0"/>
+          <a:ext cx="0" cy="0"/>
+          <a:chOff x="0" y="0"/>
+          <a:chExt cx="0" cy="0"/>
+        </a:xfrm>
+      </p:grpSpPr>
+      <p:sp>
+        <p:nvSpPr>
+          <p:cNvPr id="2" name="Slide Image Placeholder 1"/>
+          <p:cNvSpPr>
+            <a:spLocks noGrp="1" noRot="1" noChangeAspect="1"/>
+          </p:cNvSpPr>
+          <p:nvPr>
+            <p:ph type="sldImg"/>
+          </p:nvPr>
+        </p:nvSpPr>
+        <p:spPr/>
+      </p:sp>
+      <p:sp>
+        <p:nvSpPr>
+          <p:cNvPr id="3" name="Notes Placeholder 2"/>
+          <p:cNvSpPr>
+            <a:spLocks noGrp="1"/>
+          </p:cNvSpPr>
+          <p:nvPr>
+            <p:ph type="body" idx="1"/>
+          </p:nvPr>
+        </p:nvSpPr>
+        <p:spPr/>
+        <p:txBody>
+          <a:bodyPr/>
+          <a:lstStyle/>
+          <a:p>
+            <a:endParaRPr lang="en-US" dirty="0"/>
+          </a:p>
+        </p:txBody>
+      </p:sp>
+      <p:sp>
+        <p:nvSpPr>
+          <p:cNvPr id="4" name="Slide Number Placeholder 3"/>
+          <p:cNvSpPr>
+            <a:spLocks noGrp="1"/>
+          </p:cNvSpPr>
+          <p:nvPr>
+            <p:ph type="sldNum" sz="quarter" idx="5"/>
+          </p:nvPr>
+        </p:nvSpPr>
+        <p:spPr/>
+        <p:txBody>
+          <a:bodyPr/>
+          <a:lstStyle/>
+          <a:p>
+            <a:fld id="{5CD3C02A-94A9-4E52-835F-B6DB969C9D81}" type="slidenum">
+              <a:rPr lang="en-US" smtClean="0"/>
+              <a:t>1</a:t>
+            </a:fld>
+            <a:endParaRPr lang="en-US"/>
+          </a:p>
+        </p:txBody>
+      </p:sp>
+    </p:spTree>
+    <p:extLst>
+      <p:ext uri="{BB962C8B-B14F-4D97-AF65-F5344CB8AC3E}">
+        <p14:creationId xmlns:p14="http://schemas.microsoft.com/office/powerpoint/2010/main" val="919738483"/>
+      </p:ext>
+    </p:extLst>
+  </p:cSld>
+  <p:clrMapOvr>
+    <a:masterClrMapping/>
+  </p:clrMapOvr>
+</p:notes>
 </file>
 
 <file path=ppt/slideLayouts/slideLayout1.xml><?xml version="1.0" encoding="utf-8"?>
@@ -6070,6 +6154,156 @@
           </a:prstGeom>
         </p:spPr>
       </p:pic>
+      <p:cxnSp>
+        <p:nvCxnSpPr>
+          <p:cNvPr id="4" name="Straight Arrow Connector 3">
+            <a:extLst>
+              <a:ext uri="{FF2B5EF4-FFF2-40B4-BE49-F238E27FC236}">
+                <a16:creationId xmlns:a16="http://schemas.microsoft.com/office/drawing/2014/main" id="{F6F708E8-064B-EE1F-65E4-FC71D8F4BDD3}"/>
+              </a:ext>
+            </a:extLst>
+          </p:cNvPr>
+          <p:cNvCxnSpPr/>
+          <p:nvPr/>
+        </p:nvCxnSpPr>
+        <p:spPr>
+          <a:xfrm flipH="1">
+            <a:off x="397565" y="3429000"/>
+            <a:ext cx="844826" cy="0"/>
+          </a:xfrm>
+          <a:prstGeom prst="straightConnector1">
+            <a:avLst/>
+          </a:prstGeom>
+          <a:ln w="76200">
+            <a:tailEnd type="triangle"/>
+          </a:ln>
+        </p:spPr>
+        <p:style>
+          <a:lnRef idx="2">
+            <a:schemeClr val="accent1"/>
+          </a:lnRef>
+          <a:fillRef idx="0">
+            <a:schemeClr val="accent1"/>
+          </a:fillRef>
+          <a:effectRef idx="1">
+            <a:schemeClr val="accent1"/>
+          </a:effectRef>
+          <a:fontRef idx="minor">
+            <a:schemeClr val="tx1"/>
+          </a:fontRef>
+        </p:style>
+      </p:cxnSp>
+      <p:cxnSp>
+        <p:nvCxnSpPr>
+          <p:cNvPr id="5" name="Straight Arrow Connector 4">
+            <a:extLst>
+              <a:ext uri="{FF2B5EF4-FFF2-40B4-BE49-F238E27FC236}">
+                <a16:creationId xmlns:a16="http://schemas.microsoft.com/office/drawing/2014/main" id="{6284D155-4F6A-5835-A1D1-48FE05691EE4}"/>
+              </a:ext>
+            </a:extLst>
+          </p:cNvPr>
+          <p:cNvCxnSpPr>
+            <a:cxnSpLocks/>
+          </p:cNvCxnSpPr>
+          <p:nvPr/>
+        </p:nvCxnSpPr>
+        <p:spPr>
+          <a:xfrm>
+            <a:off x="10817088" y="3429000"/>
+            <a:ext cx="858077" cy="0"/>
+          </a:xfrm>
+          <a:prstGeom prst="straightConnector1">
+            <a:avLst/>
+          </a:prstGeom>
+          <a:ln w="76200">
+            <a:tailEnd type="triangle"/>
+          </a:ln>
+        </p:spPr>
+        <p:style>
+          <a:lnRef idx="2">
+            <a:schemeClr val="accent1"/>
+          </a:lnRef>
+          <a:fillRef idx="0">
+            <a:schemeClr val="accent1"/>
+          </a:fillRef>
+          <a:effectRef idx="1">
+            <a:schemeClr val="accent1"/>
+          </a:effectRef>
+          <a:fontRef idx="minor">
+            <a:schemeClr val="tx1"/>
+          </a:fontRef>
+        </p:style>
+      </p:cxnSp>
+      <p:sp>
+        <p:nvSpPr>
+          <p:cNvPr id="7" name="TextBox 6">
+            <a:extLst>
+              <a:ext uri="{FF2B5EF4-FFF2-40B4-BE49-F238E27FC236}">
+                <a16:creationId xmlns:a16="http://schemas.microsoft.com/office/drawing/2014/main" id="{A585C86B-9F0B-6536-29F6-0961CE202BDC}"/>
+              </a:ext>
+            </a:extLst>
+          </p:cNvPr>
+          <p:cNvSpPr txBox="1"/>
+          <p:nvPr/>
+        </p:nvSpPr>
+        <p:spPr>
+          <a:xfrm>
+            <a:off x="10747514" y="2866537"/>
+            <a:ext cx="793166" cy="369332"/>
+          </a:xfrm>
+          <a:prstGeom prst="rect">
+            <a:avLst/>
+          </a:prstGeom>
+          <a:noFill/>
+        </p:spPr>
+        <p:txBody>
+          <a:bodyPr wrap="none" rtlCol="0">
+            <a:spAutoFit/>
+          </a:bodyPr>
+          <a:lstStyle/>
+          <a:p>
+            <a:r>
+              <a:rPr lang="en-US" dirty="0"/>
+              <a:t>Elbow</a:t>
+            </a:r>
+          </a:p>
+        </p:txBody>
+      </p:sp>
+      <p:sp>
+        <p:nvSpPr>
+          <p:cNvPr id="9" name="TextBox 8">
+            <a:extLst>
+              <a:ext uri="{FF2B5EF4-FFF2-40B4-BE49-F238E27FC236}">
+                <a16:creationId xmlns:a16="http://schemas.microsoft.com/office/drawing/2014/main" id="{B28CFBB5-9D59-2FE5-73B2-A594366A5BC1}"/>
+              </a:ext>
+            </a:extLst>
+          </p:cNvPr>
+          <p:cNvSpPr txBox="1"/>
+          <p:nvPr/>
+        </p:nvSpPr>
+        <p:spPr>
+          <a:xfrm>
+            <a:off x="449225" y="2866537"/>
+            <a:ext cx="728084" cy="369332"/>
+          </a:xfrm>
+          <a:prstGeom prst="rect">
+            <a:avLst/>
+          </a:prstGeom>
+          <a:noFill/>
+        </p:spPr>
+        <p:txBody>
+          <a:bodyPr wrap="none" rtlCol="0">
+            <a:spAutoFit/>
+          </a:bodyPr>
+          <a:lstStyle/>
+          <a:p>
+            <a:r>
+              <a:rPr lang="en-US" dirty="0"/>
+              <a:t>Hand</a:t>
+            </a:r>
+          </a:p>
+        </p:txBody>
+      </p:sp>
     </p:spTree>
     <p:extLst>
       <p:ext uri="{BB962C8B-B14F-4D97-AF65-F5344CB8AC3E}">
@@ -6151,13 +6385,13 @@
           <a:p>
             <a:r>
               <a:rPr lang="en-US" dirty="0"/>
-              <a:t>PCB Review / Correct the designs / Order</a:t>
+              <a:t>Scholarships applications</a:t>
             </a:r>
           </a:p>
           <a:p>
             <a:r>
               <a:rPr lang="en-US" dirty="0"/>
-              <a:t>Scholarships applications</a:t>
+              <a:t>PCB Review / Correct the designs / Order</a:t>
             </a:r>
           </a:p>
           <a:p>

</xml_diff>